<commit_message>
Rewrite Lecture 7: real CSS alongside the positioning and overflow screenshots
Most image slides here already had a matching code slide right before
them (card badge, z-index, float wrap, clearfix) -- left those as is.
Converted the two still image-only: the five-positioning-schemes
comparison (now shows all five position values at once) and the
overflow visible-vs-hidden comparison.

Co-Authored-By: Claude Sonnet 5 <noreply@anthropic.com>
</commit_message>
<xml_diff>
--- a/slides/CSC336-Lecture-07-CSS-Positioning-and-Stacking.pptx
+++ b/slides/CSC336-Lecture-07-CSS-Positioning-and-Stacking.pptx
@@ -3743,11 +3743,11 @@
         <p:spPr>
           <a:xfrm>
             <a:off x="640080" y="1965960"/>
-            <a:ext cx="10911535" cy="2990088"/>
+            <a:ext cx="10911535" cy="2148840"/>
           </a:xfrm>
           <a:prstGeom prst="roundRect">
             <a:avLst>
-              <a:gd name="adj" fmla="val 2446"/>
+              <a:gd name="adj" fmla="val 3404"/>
             </a:avLst>
           </a:prstGeom>
           <a:solidFill>
@@ -3765,7 +3765,7 @@
         <p:spPr>
           <a:xfrm>
             <a:off x="960120" y="2194560"/>
-            <a:ext cx="10271455" cy="2532888"/>
+            <a:ext cx="10271455" cy="1691640"/>
           </a:xfrm>
           <a:prstGeom prst="rect">
             <a:avLst/>
@@ -3895,8 +3895,8 @@
         </p:nvSpPr>
         <p:spPr>
           <a:xfrm>
-            <a:off x="640080" y="5184648"/>
-            <a:ext cx="10911535" cy="1078992"/>
+            <a:off x="640080" y="4343400"/>
+            <a:ext cx="10911535" cy="1920240"/>
           </a:xfrm>
           <a:prstGeom prst="rect">
             <a:avLst/>
@@ -4369,11 +4369,11 @@
         <p:spPr>
           <a:xfrm>
             <a:off x="640080" y="1965960"/>
-            <a:ext cx="10911535" cy="1837944"/>
+            <a:ext cx="10911535" cy="1348740"/>
           </a:xfrm>
           <a:prstGeom prst="roundRect">
             <a:avLst>
-              <a:gd name="adj" fmla="val 3980"/>
+              <a:gd name="adj" fmla="val 5424"/>
             </a:avLst>
           </a:prstGeom>
           <a:solidFill>
@@ -4391,7 +4391,7 @@
         <p:spPr>
           <a:xfrm>
             <a:off x="960120" y="2194560"/>
-            <a:ext cx="10271455" cy="1380744"/>
+            <a:ext cx="10271455" cy="891540"/>
           </a:xfrm>
           <a:prstGeom prst="rect">
             <a:avLst/>
@@ -4472,8 +4472,8 @@
         </p:nvSpPr>
         <p:spPr>
           <a:xfrm>
-            <a:off x="640080" y="4032504"/>
-            <a:ext cx="10911535" cy="2231136"/>
+            <a:off x="640080" y="3543300"/>
+            <a:ext cx="10911535" cy="2720340"/>
           </a:xfrm>
           <a:prstGeom prst="rect">
             <a:avLst/>
@@ -4700,11 +4700,11 @@
         <p:spPr>
           <a:xfrm>
             <a:off x="640080" y="1965960"/>
-            <a:ext cx="10911535" cy="1453896"/>
+            <a:ext cx="10911535" cy="1082040"/>
           </a:xfrm>
           <a:prstGeom prst="roundRect">
             <a:avLst>
-              <a:gd name="adj" fmla="val 5031"/>
+              <a:gd name="adj" fmla="val 6761"/>
             </a:avLst>
           </a:prstGeom>
           <a:solidFill>
@@ -4722,7 +4722,7 @@
         <p:spPr>
           <a:xfrm>
             <a:off x="960120" y="2194560"/>
-            <a:ext cx="10271455" cy="996696"/>
+            <a:ext cx="10271455" cy="624840"/>
           </a:xfrm>
           <a:prstGeom prst="rect">
             <a:avLst/>
@@ -4783,8 +4783,8 @@
         </p:nvSpPr>
         <p:spPr>
           <a:xfrm>
-            <a:off x="640080" y="3648456"/>
-            <a:ext cx="10911535" cy="2615184"/>
+            <a:off x="640080" y="3276600"/>
+            <a:ext cx="10911535" cy="2987040"/>
           </a:xfrm>
           <a:prstGeom prst="rect">
             <a:avLst/>
@@ -5622,11 +5622,11 @@
         <p:spPr>
           <a:xfrm>
             <a:off x="640080" y="1965960"/>
-            <a:ext cx="10911535" cy="1069848"/>
+            <a:ext cx="10911535" cy="815340"/>
           </a:xfrm>
           <a:prstGeom prst="roundRect">
             <a:avLst>
-              <a:gd name="adj" fmla="val 6838"/>
+              <a:gd name="adj" fmla="val 8972"/>
             </a:avLst>
           </a:prstGeom>
           <a:solidFill>
@@ -5644,7 +5644,7 @@
         <p:spPr>
           <a:xfrm>
             <a:off x="960120" y="2194560"/>
-            <a:ext cx="10271455" cy="612648"/>
+            <a:ext cx="10271455" cy="358140"/>
           </a:xfrm>
           <a:prstGeom prst="rect">
             <a:avLst/>
@@ -5685,8 +5685,8 @@
         </p:nvSpPr>
         <p:spPr>
           <a:xfrm>
-            <a:off x="640080" y="3264408"/>
-            <a:ext cx="10911535" cy="2999232"/>
+            <a:off x="640080" y="3009900"/>
+            <a:ext cx="10911535" cy="3253740"/>
           </a:xfrm>
           <a:prstGeom prst="rect">
             <a:avLst/>
@@ -6159,11 +6159,11 @@
         <p:spPr>
           <a:xfrm>
             <a:off x="640080" y="1965960"/>
-            <a:ext cx="10911535" cy="2221992"/>
+            <a:ext cx="10911535" cy="1615440"/>
           </a:xfrm>
           <a:prstGeom prst="roundRect">
             <a:avLst>
-              <a:gd name="adj" fmla="val 3292"/>
+              <a:gd name="adj" fmla="val 4528"/>
             </a:avLst>
           </a:prstGeom>
           <a:solidFill>
@@ -6181,7 +6181,7 @@
         <p:spPr>
           <a:xfrm>
             <a:off x="960120" y="2194560"/>
-            <a:ext cx="10271455" cy="1764792"/>
+            <a:ext cx="10271455" cy="1158240"/>
           </a:xfrm>
           <a:prstGeom prst="rect">
             <a:avLst/>
@@ -6282,8 +6282,8 @@
         </p:nvSpPr>
         <p:spPr>
           <a:xfrm>
-            <a:off x="640080" y="4416552"/>
-            <a:ext cx="10911535" cy="1847088"/>
+            <a:off x="640080" y="3810000"/>
+            <a:ext cx="10911535" cy="2453640"/>
           </a:xfrm>
           <a:prstGeom prst="rect">
             <a:avLst/>
@@ -6510,11 +6510,11 @@
         <p:spPr>
           <a:xfrm>
             <a:off x="640080" y="1965960"/>
-            <a:ext cx="10911535" cy="2606040"/>
+            <a:ext cx="10911535" cy="1882140"/>
           </a:xfrm>
           <a:prstGeom prst="roundRect">
             <a:avLst>
-              <a:gd name="adj" fmla="val 2807"/>
+              <a:gd name="adj" fmla="val 3887"/>
             </a:avLst>
           </a:prstGeom>
           <a:solidFill>
@@ -6532,7 +6532,7 @@
         <p:spPr>
           <a:xfrm>
             <a:off x="960120" y="2194560"/>
-            <a:ext cx="10271455" cy="2148840"/>
+            <a:ext cx="10271455" cy="1424940"/>
           </a:xfrm>
           <a:prstGeom prst="rect">
             <a:avLst/>
@@ -6642,8 +6642,8 @@
         </p:nvSpPr>
         <p:spPr>
           <a:xfrm>
-            <a:off x="640080" y="4800600"/>
-            <a:ext cx="10911535" cy="1463040"/>
+            <a:off x="640080" y="4076700"/>
+            <a:ext cx="10911535" cy="2186940"/>
           </a:xfrm>
           <a:prstGeom prst="rect">
             <a:avLst/>
@@ -8683,11 +8683,11 @@
         <p:spPr>
           <a:xfrm>
             <a:off x="640080" y="1965960"/>
-            <a:ext cx="10911535" cy="1837944"/>
+            <a:ext cx="10911535" cy="1348740"/>
           </a:xfrm>
           <a:prstGeom prst="roundRect">
             <a:avLst>
-              <a:gd name="adj" fmla="val 3980"/>
+              <a:gd name="adj" fmla="val 5424"/>
             </a:avLst>
           </a:prstGeom>
           <a:solidFill>
@@ -8705,7 +8705,7 @@
         <p:spPr>
           <a:xfrm>
             <a:off x="960120" y="2194560"/>
-            <a:ext cx="10271455" cy="1380744"/>
+            <a:ext cx="10271455" cy="891540"/>
           </a:xfrm>
           <a:prstGeom prst="rect">
             <a:avLst/>
@@ -8786,8 +8786,8 @@
         </p:nvSpPr>
         <p:spPr>
           <a:xfrm>
-            <a:off x="640080" y="4032504"/>
-            <a:ext cx="10911535" cy="2231136"/>
+            <a:off x="640080" y="3543300"/>
+            <a:ext cx="10911535" cy="2720340"/>
           </a:xfrm>
           <a:prstGeom prst="rect">
             <a:avLst/>
@@ -9014,11 +9014,11 @@
         <p:spPr>
           <a:xfrm>
             <a:off x="640080" y="1965960"/>
-            <a:ext cx="10911535" cy="2606040"/>
+            <a:ext cx="10911535" cy="1882140"/>
           </a:xfrm>
           <a:prstGeom prst="roundRect">
             <a:avLst>
-              <a:gd name="adj" fmla="val 2807"/>
+              <a:gd name="adj" fmla="val 3887"/>
             </a:avLst>
           </a:prstGeom>
           <a:solidFill>
@@ -9036,7 +9036,7 @@
         <p:spPr>
           <a:xfrm>
             <a:off x="960120" y="2194560"/>
-            <a:ext cx="10271455" cy="2148840"/>
+            <a:ext cx="10271455" cy="1424940"/>
           </a:xfrm>
           <a:prstGeom prst="rect">
             <a:avLst/>
@@ -9157,8 +9157,8 @@
         </p:nvSpPr>
         <p:spPr>
           <a:xfrm>
-            <a:off x="640080" y="4800600"/>
-            <a:ext cx="10911535" cy="1463040"/>
+            <a:off x="640080" y="4076700"/>
+            <a:ext cx="10911535" cy="2186940"/>
           </a:xfrm>
           <a:prstGeom prst="rect">
             <a:avLst/>
@@ -10400,12 +10400,176 @@
         </p:nvSpPr>
         <p:spPr>
           <a:xfrm>
-            <a:off x="530352" y="1947672"/>
-            <a:ext cx="11130991" cy="4334256"/>
+            <a:off x="640080" y="1965960"/>
+            <a:ext cx="10911535" cy="1977390"/>
           </a:xfrm>
           <a:prstGeom prst="roundRect">
             <a:avLst>
-              <a:gd name="adj" fmla="val 1266"/>
+              <a:gd name="adj" fmla="val 3699"/>
+            </a:avLst>
+          </a:prstGeom>
+          <a:solidFill>
+            <a:srgbClr val="1E1E4C"/>
+          </a:solidFill>
+          <a:ln/>
+        </p:spPr>
+      </p:sp>
+      <p:sp>
+        <p:nvSpPr>
+          <p:cNvPr id="5" name="Text 3"/>
+          <p:cNvSpPr txBox="1"/>
+          <p:nvPr/>
+        </p:nvSpPr>
+        <p:spPr>
+          <a:xfrm>
+            <a:off x="960120" y="2194560"/>
+            <a:ext cx="10271455" cy="1520190"/>
+          </a:xfrm>
+          <a:prstGeom prst="rect">
+            <a:avLst/>
+          </a:prstGeom>
+          <a:noFill/>
+          <a:ln/>
+        </p:spPr>
+        <p:txBody>
+          <a:bodyPr wrap="square" lIns="0" tIns="0" rIns="0" bIns="0" rtlCol="0" anchor="t"/>
+          <a:lstStyle/>
+          <a:p>
+            <a:pPr indent="0" marL="0">
+              <a:lnSpc>
+                <a:spcPct val="125000"/>
+              </a:lnSpc>
+              <a:buNone/>
+            </a:pPr>
+            <a:r>
+              <a:rPr lang="en-US" sz="1250" dirty="0">
+                <a:solidFill>
+                  <a:srgbClr val="C9D3F5"/>
+                </a:solidFill>
+                <a:latin typeface="Courier New" pitchFamily="34" charset="0"/>
+                <a:ea typeface="Courier New" pitchFamily="34" charset="-122"/>
+                <a:cs typeface="Courier New" pitchFamily="34" charset="-120"/>
+              </a:rPr>
+              <a:t>.box {</a:t>
+            </a:r>
+            <a:endParaRPr lang="en-US" sz="1250" dirty="0"/>
+          </a:p>
+          <a:p>
+            <a:pPr indent="0" marL="0">
+              <a:lnSpc>
+                <a:spcPct val="125000"/>
+              </a:lnSpc>
+              <a:buNone/>
+            </a:pPr>
+            <a:r>
+              <a:rPr lang="en-US" sz="1250" dirty="0">
+                <a:solidFill>
+                  <a:srgbClr val="C9D3F5"/>
+                </a:solidFill>
+                <a:latin typeface="Courier New" pitchFamily="34" charset="0"/>
+                <a:ea typeface="Courier New" pitchFamily="34" charset="-122"/>
+                <a:cs typeface="Courier New" pitchFamily="34" charset="-120"/>
+              </a:rPr>
+              <a:t>  width: 200px;</a:t>
+            </a:r>
+            <a:endParaRPr lang="en-US" sz="1250" dirty="0"/>
+          </a:p>
+          <a:p>
+            <a:pPr indent="0" marL="0">
+              <a:lnSpc>
+                <a:spcPct val="125000"/>
+              </a:lnSpc>
+              <a:buNone/>
+            </a:pPr>
+            <a:r>
+              <a:rPr lang="en-US" sz="1250" dirty="0">
+                <a:solidFill>
+                  <a:srgbClr val="C9D3F5"/>
+                </a:solidFill>
+                <a:latin typeface="Courier New" pitchFamily="34" charset="0"/>
+                <a:ea typeface="Courier New" pitchFamily="34" charset="-122"/>
+                <a:cs typeface="Courier New" pitchFamily="34" charset="-120"/>
+              </a:rPr>
+              <a:t>  height: 100px;</a:t>
+            </a:r>
+            <a:endParaRPr lang="en-US" sz="1250" dirty="0"/>
+          </a:p>
+          <a:p>
+            <a:pPr indent="0" marL="0">
+              <a:lnSpc>
+                <a:spcPct val="125000"/>
+              </a:lnSpc>
+              <a:buNone/>
+            </a:pPr>
+            <a:r>
+              <a:rPr lang="en-US" sz="1250" dirty="0">
+                <a:solidFill>
+                  <a:srgbClr val="C9D3F5"/>
+                </a:solidFill>
+                <a:latin typeface="Courier New" pitchFamily="34" charset="0"/>
+                <a:ea typeface="Courier New" pitchFamily="34" charset="-122"/>
+                <a:cs typeface="Courier New" pitchFamily="34" charset="-120"/>
+              </a:rPr>
+              <a:t>  overflow: visible; /* default: extra content spills out */</a:t>
+            </a:r>
+            <a:endParaRPr lang="en-US" sz="1250" dirty="0"/>
+          </a:p>
+          <a:p>
+            <a:pPr indent="0" marL="0">
+              <a:lnSpc>
+                <a:spcPct val="125000"/>
+              </a:lnSpc>
+              <a:buNone/>
+            </a:pPr>
+            <a:r>
+              <a:rPr lang="en-US" sz="1250" dirty="0">
+                <a:solidFill>
+                  <a:srgbClr val="C9D3F5"/>
+                </a:solidFill>
+                <a:latin typeface="Courier New" pitchFamily="34" charset="0"/>
+                <a:ea typeface="Courier New" pitchFamily="34" charset="-122"/>
+                <a:cs typeface="Courier New" pitchFamily="34" charset="-120"/>
+              </a:rPr>
+              <a:t>  /* overflow: hidden;  clips content that doesn't fit  */</a:t>
+            </a:r>
+            <a:endParaRPr lang="en-US" sz="1250" dirty="0"/>
+          </a:p>
+          <a:p>
+            <a:pPr indent="0" marL="0">
+              <a:lnSpc>
+                <a:spcPct val="125000"/>
+              </a:lnSpc>
+              <a:buNone/>
+            </a:pPr>
+            <a:r>
+              <a:rPr lang="en-US" sz="1250" dirty="0">
+                <a:solidFill>
+                  <a:srgbClr val="C9D3F5"/>
+                </a:solidFill>
+                <a:latin typeface="Courier New" pitchFamily="34" charset="0"/>
+                <a:ea typeface="Courier New" pitchFamily="34" charset="-122"/>
+                <a:cs typeface="Courier New" pitchFamily="34" charset="-120"/>
+              </a:rPr>
+              <a:t>}</a:t>
+            </a:r>
+            <a:endParaRPr lang="en-US" sz="1250" dirty="0"/>
+          </a:p>
+        </p:txBody>
+      </p:sp>
+      <p:sp>
+        <p:nvSpPr>
+          <p:cNvPr id="6" name="Shape 4"/>
+          <p:cNvSpPr/>
+          <p:nvPr/>
+        </p:nvSpPr>
+        <p:spPr>
+          <a:xfrm>
+            <a:off x="530352" y="4107942"/>
+            <a:ext cx="11130991" cy="2219706"/>
+          </a:xfrm>
+          <a:prstGeom prst="roundRect">
+            <a:avLst>
+              <a:gd name="adj" fmla="val 2472"/>
             </a:avLst>
           </a:prstGeom>
           <a:solidFill>
@@ -10428,7 +10592,7 @@
       </p:sp>
       <p:pic>
         <p:nvPicPr>
-          <p:cNvPr id="5" name="Image 0" descr="D:/GitHub/mern-web-book/docs/assets/img/lecture-07/overflow-comparison.png">    </p:cNvPr>
+          <p:cNvPr id="7" name="Image 0" descr="D:/GitHub/mern-web-book/docs/assets/img/lecture-07/overflow-comparison.png">    </p:cNvPr>
           <p:cNvPicPr>
             <a:picLocks noChangeAspect="1"/>
           </p:cNvPicPr>
@@ -10442,8 +10606,8 @@
         </p:blipFill>
         <p:spPr>
           <a:xfrm>
-            <a:off x="843031" y="2057400"/>
-            <a:ext cx="10505634" cy="4114800"/>
+            <a:off x="3542395" y="4217670"/>
+            <a:ext cx="5106905" cy="2000250"/>
           </a:xfrm>
           <a:prstGeom prst="rect">
             <a:avLst/>
@@ -10452,7 +10616,7 @@
       </p:pic>
       <p:sp>
         <p:nvSpPr>
-          <p:cNvPr id="6" name="Text 3"/>
+          <p:cNvPr id="8" name="Text 5"/>
           <p:cNvSpPr txBox="1"/>
           <p:nvPr/>
         </p:nvSpPr>
@@ -10491,7 +10655,7 @@
       </p:sp>
       <p:sp>
         <p:nvSpPr>
-          <p:cNvPr id="7" name="Text 4"/>
+          <p:cNvPr id="9" name="Text 6"/>
           <p:cNvSpPr txBox="1"/>
           <p:nvPr/>
         </p:nvSpPr>
@@ -12660,12 +12824,156 @@
         </p:nvSpPr>
         <p:spPr>
           <a:xfrm>
-            <a:off x="530352" y="2221992"/>
-            <a:ext cx="11130991" cy="4059936"/>
+            <a:off x="640080" y="2240280"/>
+            <a:ext cx="10911535" cy="1739265"/>
           </a:xfrm>
           <a:prstGeom prst="roundRect">
             <a:avLst>
-              <a:gd name="adj" fmla="val 1351"/>
+              <a:gd name="adj" fmla="val 4206"/>
+            </a:avLst>
+          </a:prstGeom>
+          <a:solidFill>
+            <a:srgbClr val="1E1E4C"/>
+          </a:solidFill>
+          <a:ln/>
+        </p:spPr>
+      </p:sp>
+      <p:sp>
+        <p:nvSpPr>
+          <p:cNvPr id="6" name="Text 4"/>
+          <p:cNvSpPr txBox="1"/>
+          <p:nvPr/>
+        </p:nvSpPr>
+        <p:spPr>
+          <a:xfrm>
+            <a:off x="960120" y="2468880"/>
+            <a:ext cx="10271455" cy="1282065"/>
+          </a:xfrm>
+          <a:prstGeom prst="rect">
+            <a:avLst/>
+          </a:prstGeom>
+          <a:noFill/>
+          <a:ln/>
+        </p:spPr>
+        <p:txBody>
+          <a:bodyPr wrap="square" lIns="0" tIns="0" rIns="0" bIns="0" rtlCol="0" anchor="t"/>
+          <a:lstStyle/>
+          <a:p>
+            <a:pPr indent="0" marL="0">
+              <a:lnSpc>
+                <a:spcPct val="125000"/>
+              </a:lnSpc>
+              <a:buNone/>
+            </a:pPr>
+            <a:r>
+              <a:rPr lang="en-US" sz="1250" dirty="0">
+                <a:solidFill>
+                  <a:srgbClr val="C9D3F5"/>
+                </a:solidFill>
+                <a:latin typeface="Courier New" pitchFamily="34" charset="0"/>
+                <a:ea typeface="Courier New" pitchFamily="34" charset="-122"/>
+                <a:cs typeface="Courier New" pitchFamily="34" charset="-120"/>
+              </a:rPr>
+              <a:t>.static   { position: static; }</a:t>
+            </a:r>
+            <a:endParaRPr lang="en-US" sz="1250" dirty="0"/>
+          </a:p>
+          <a:p>
+            <a:pPr indent="0" marL="0">
+              <a:lnSpc>
+                <a:spcPct val="125000"/>
+              </a:lnSpc>
+              <a:buNone/>
+            </a:pPr>
+            <a:r>
+              <a:rPr lang="en-US" sz="1250" dirty="0">
+                <a:solidFill>
+                  <a:srgbClr val="C9D3F5"/>
+                </a:solidFill>
+                <a:latin typeface="Courier New" pitchFamily="34" charset="0"/>
+                <a:ea typeface="Courier New" pitchFamily="34" charset="-122"/>
+                <a:cs typeface="Courier New" pitchFamily="34" charset="-120"/>
+              </a:rPr>
+              <a:t>.relative { position: relative; top: 10px; left: 20px; }</a:t>
+            </a:r>
+            <a:endParaRPr lang="en-US" sz="1250" dirty="0"/>
+          </a:p>
+          <a:p>
+            <a:pPr indent="0" marL="0">
+              <a:lnSpc>
+                <a:spcPct val="125000"/>
+              </a:lnSpc>
+              <a:buNone/>
+            </a:pPr>
+            <a:r>
+              <a:rPr lang="en-US" sz="1250" dirty="0">
+                <a:solidFill>
+                  <a:srgbClr val="C9D3F5"/>
+                </a:solidFill>
+                <a:latin typeface="Courier New" pitchFamily="34" charset="0"/>
+                <a:ea typeface="Courier New" pitchFamily="34" charset="-122"/>
+                <a:cs typeface="Courier New" pitchFamily="34" charset="-120"/>
+              </a:rPr>
+              <a:t>.absolute { position: absolute; top: 0; right: 0; }</a:t>
+            </a:r>
+            <a:endParaRPr lang="en-US" sz="1250" dirty="0"/>
+          </a:p>
+          <a:p>
+            <a:pPr indent="0" marL="0">
+              <a:lnSpc>
+                <a:spcPct val="125000"/>
+              </a:lnSpc>
+              <a:buNone/>
+            </a:pPr>
+            <a:r>
+              <a:rPr lang="en-US" sz="1250" dirty="0">
+                <a:solidFill>
+                  <a:srgbClr val="C9D3F5"/>
+                </a:solidFill>
+                <a:latin typeface="Courier New" pitchFamily="34" charset="0"/>
+                <a:ea typeface="Courier New" pitchFamily="34" charset="-122"/>
+                <a:cs typeface="Courier New" pitchFamily="34" charset="-120"/>
+              </a:rPr>
+              <a:t>.fixed    { position: fixed; bottom: 20px; right: 20px; }</a:t>
+            </a:r>
+            <a:endParaRPr lang="en-US" sz="1250" dirty="0"/>
+          </a:p>
+          <a:p>
+            <a:pPr indent="0" marL="0">
+              <a:lnSpc>
+                <a:spcPct val="125000"/>
+              </a:lnSpc>
+              <a:buNone/>
+            </a:pPr>
+            <a:r>
+              <a:rPr lang="en-US" sz="1250" dirty="0">
+                <a:solidFill>
+                  <a:srgbClr val="C9D3F5"/>
+                </a:solidFill>
+                <a:latin typeface="Courier New" pitchFamily="34" charset="0"/>
+                <a:ea typeface="Courier New" pitchFamily="34" charset="-122"/>
+                <a:cs typeface="Courier New" pitchFamily="34" charset="-120"/>
+              </a:rPr>
+              <a:t>.sticky   { position: sticky; top: 0; }</a:t>
+            </a:r>
+            <a:endParaRPr lang="en-US" sz="1250" dirty="0"/>
+          </a:p>
+        </p:txBody>
+      </p:sp>
+      <p:sp>
+        <p:nvSpPr>
+          <p:cNvPr id="7" name="Shape 5"/>
+          <p:cNvSpPr/>
+          <p:nvPr/>
+        </p:nvSpPr>
+        <p:spPr>
+          <a:xfrm>
+            <a:off x="530352" y="4144137"/>
+            <a:ext cx="11130991" cy="2183511"/>
+          </a:xfrm>
+          <a:prstGeom prst="roundRect">
+            <a:avLst>
+              <a:gd name="adj" fmla="val 2513"/>
             </a:avLst>
           </a:prstGeom>
           <a:solidFill>
@@ -12688,7 +12996,7 @@
       </p:sp>
       <p:pic>
         <p:nvPicPr>
-          <p:cNvPr id="6" name="Image 0" descr="D:/GitHub/mern-web-book/docs/assets/img/lecture-07/position-values-comparison.png">    </p:cNvPr>
+          <p:cNvPr id="8" name="Image 0" descr="D:/GitHub/mern-web-book/docs/assets/img/lecture-07/position-values-comparison.png">    </p:cNvPr>
           <p:cNvPicPr>
             <a:picLocks noChangeAspect="1"/>
           </p:cNvPicPr>
@@ -12702,8 +13010,8 @@
         </p:blipFill>
         <p:spPr>
           <a:xfrm>
-            <a:off x="4961543" y="2331720"/>
-            <a:ext cx="2268610" cy="3840480"/>
+            <a:off x="5515754" y="4253865"/>
+            <a:ext cx="1160187" cy="1964055"/>
           </a:xfrm>
           <a:prstGeom prst="rect">
             <a:avLst/>
@@ -12712,7 +13020,7 @@
       </p:pic>
       <p:sp>
         <p:nvSpPr>
-          <p:cNvPr id="7" name="Text 4"/>
+          <p:cNvPr id="9" name="Text 6"/>
           <p:cNvSpPr txBox="1"/>
           <p:nvPr/>
         </p:nvSpPr>
@@ -12751,7 +13059,7 @@
       </p:sp>
       <p:sp>
         <p:nvSpPr>
-          <p:cNvPr id="8" name="Text 5"/>
+          <p:cNvPr id="10" name="Text 7"/>
           <p:cNvSpPr txBox="1"/>
           <p:nvPr/>
         </p:nvSpPr>
@@ -12907,11 +13215,11 @@
         <p:spPr>
           <a:xfrm>
             <a:off x="640080" y="1965960"/>
-            <a:ext cx="10911535" cy="2606040"/>
+            <a:ext cx="10911535" cy="1882140"/>
           </a:xfrm>
           <a:prstGeom prst="roundRect">
             <a:avLst>
-              <a:gd name="adj" fmla="val 2807"/>
+              <a:gd name="adj" fmla="val 3887"/>
             </a:avLst>
           </a:prstGeom>
           <a:solidFill>
@@ -12929,7 +13237,7 @@
         <p:spPr>
           <a:xfrm>
             <a:off x="960120" y="2194560"/>
-            <a:ext cx="10271455" cy="2148840"/>
+            <a:ext cx="10271455" cy="1424940"/>
           </a:xfrm>
           <a:prstGeom prst="rect">
             <a:avLst/>
@@ -13050,8 +13358,8 @@
         </p:nvSpPr>
         <p:spPr>
           <a:xfrm>
-            <a:off x="640080" y="4800600"/>
-            <a:ext cx="10911535" cy="1463040"/>
+            <a:off x="640080" y="4076700"/>
+            <a:ext cx="10911535" cy="2186940"/>
           </a:xfrm>
           <a:prstGeom prst="rect">
             <a:avLst/>
@@ -13278,11 +13586,11 @@
         <p:spPr>
           <a:xfrm>
             <a:off x="640080" y="1965960"/>
-            <a:ext cx="10911535" cy="2606040"/>
+            <a:ext cx="10911535" cy="1882140"/>
           </a:xfrm>
           <a:prstGeom prst="roundRect">
             <a:avLst>
-              <a:gd name="adj" fmla="val 2807"/>
+              <a:gd name="adj" fmla="val 3887"/>
             </a:avLst>
           </a:prstGeom>
           <a:solidFill>
@@ -13300,7 +13608,7 @@
         <p:spPr>
           <a:xfrm>
             <a:off x="960120" y="2194560"/>
-            <a:ext cx="10271455" cy="2148840"/>
+            <a:ext cx="10271455" cy="1424940"/>
           </a:xfrm>
           <a:prstGeom prst="rect">
             <a:avLst/>
@@ -13421,8 +13729,8 @@
         </p:nvSpPr>
         <p:spPr>
           <a:xfrm>
-            <a:off x="640080" y="4800600"/>
-            <a:ext cx="10911535" cy="1463040"/>
+            <a:off x="640080" y="4076700"/>
+            <a:ext cx="10911535" cy="2186940"/>
           </a:xfrm>
           <a:prstGeom prst="rect">
             <a:avLst/>
@@ -13649,11 +13957,11 @@
         <p:spPr>
           <a:xfrm>
             <a:off x="640080" y="1965960"/>
-            <a:ext cx="10911535" cy="2606040"/>
+            <a:ext cx="10911535" cy="1882140"/>
           </a:xfrm>
           <a:prstGeom prst="roundRect">
             <a:avLst>
-              <a:gd name="adj" fmla="val 2807"/>
+              <a:gd name="adj" fmla="val 3887"/>
             </a:avLst>
           </a:prstGeom>
           <a:solidFill>
@@ -13671,7 +13979,7 @@
         <p:spPr>
           <a:xfrm>
             <a:off x="960120" y="2194560"/>
-            <a:ext cx="10271455" cy="2148840"/>
+            <a:ext cx="10271455" cy="1424940"/>
           </a:xfrm>
           <a:prstGeom prst="rect">
             <a:avLst/>
@@ -13792,8 +14100,8 @@
         </p:nvSpPr>
         <p:spPr>
           <a:xfrm>
-            <a:off x="640080" y="4800600"/>
-            <a:ext cx="10911535" cy="1463040"/>
+            <a:off x="640080" y="4076700"/>
+            <a:ext cx="10911535" cy="2186940"/>
           </a:xfrm>
           <a:prstGeom prst="rect">
             <a:avLst/>
@@ -14020,11 +14328,11 @@
         <p:spPr>
           <a:xfrm>
             <a:off x="640080" y="1965960"/>
-            <a:ext cx="10911535" cy="2221992"/>
+            <a:ext cx="10911535" cy="1615440"/>
           </a:xfrm>
           <a:prstGeom prst="roundRect">
             <a:avLst>
-              <a:gd name="adj" fmla="val 3292"/>
+              <a:gd name="adj" fmla="val 4528"/>
             </a:avLst>
           </a:prstGeom>
           <a:solidFill>
@@ -14042,7 +14350,7 @@
         <p:spPr>
           <a:xfrm>
             <a:off x="960120" y="2194560"/>
-            <a:ext cx="10271455" cy="1764792"/>
+            <a:ext cx="10271455" cy="1158240"/>
           </a:xfrm>
           <a:prstGeom prst="rect">
             <a:avLst/>
@@ -14143,8 +14451,8 @@
         </p:nvSpPr>
         <p:spPr>
           <a:xfrm>
-            <a:off x="640080" y="4416552"/>
-            <a:ext cx="10911535" cy="1847088"/>
+            <a:off x="640080" y="3810000"/>
+            <a:ext cx="10911535" cy="2453640"/>
           </a:xfrm>
           <a:prstGeom prst="rect">
             <a:avLst/>

</xml_diff>